<commit_message>
feat: 9-state EKF, 3 PPTX slides, comprehensive docs with justifications
</commit_message>
<xml_diff>
--- a/proposal/Presentations/SENTINEL_GNSS_Proposal_v4.pptx
+++ b/proposal/Presentations/SENTINEL_GNSS_Proposal_v4.pptx
@@ -37,6 +37,11 @@
     <p:sldId id="285" r:id="rId36"/>
     <p:sldId id="286" r:id="rId37"/>
     <p:sldId id="287" r:id="rId38"/>
+    <p:sldId id="288" r:id="rId39"/>
+    <p:sldId id="289" r:id="rId40"/>
+    <p:sldId id="290" r:id="rId41"/>
+    <p:sldId id="291" r:id="rId42"/>
+    <p:sldId id="292" r:id="rId43"/>
   </p:sldIdLst>
   <p:sldSz cx="12191695" cy="6858000" type="screen4x3"/>
   <p:notesSz cx="6858000" cy="9144000"/>
@@ -7547,7 +7552,7 @@
                 </a:solidFill>
                 <a:latin typeface="Calibri"/>
               </a:rPr>
-              <a:t>6 · Roadmap &amp; Deliverables</a:t>
+              <a:t>5.5 · EKF: From Prediction to Position</a:t>
             </a:r>
           </a:p>
         </p:txBody>
@@ -7701,7 +7706,7 @@
                 </a:solidFill>
                 <a:latin typeface="Calibri"/>
               </a:rPr>
-              <a:t>Publication plan — 2 papers + 1 conference</a:t>
+              <a:t>How EKF Works: Predict-Update Cycle</a:t>
             </a:r>
           </a:p>
         </p:txBody>
@@ -7743,7 +7748,7 @@
                 </a:solidFill>
                 <a:latin typeface="Calibri"/>
               </a:rPr>
-              <a:t>•  Paper A (GPS Solutions, Q1): method + multi-horizon + cross-receiver + cross-city + EKF.</a:t>
+              <a:t>•  Extended Kalman Filter fuses two sources of information:</a:t>
             </a:r>
           </a:p>
           <a:p>
@@ -7762,7 +7767,7 @@
                 </a:solidFill>
                 <a:latin typeface="Calibri"/>
               </a:rPr>
-              <a:t>•  Paper B (Scientific Data / Data in Brief): the benchmark / dataset descriptor.</a:t>
+              <a:t>•  1. GNSS position measurement (noisy, but absolute positioning)</a:t>
             </a:r>
           </a:p>
           <a:p>
@@ -7781,7 +7786,7 @@
                 </a:solidFill>
                 <a:latin typeface="Calibri"/>
               </a:rPr>
-              <a:t>•  Conference (ION GNSS+ 2026): cross-city result as a short paper, later extended.</a:t>
+              <a:t>•  2. Motion model (dead-reckoning via velocity, but drifts over time)</a:t>
             </a:r>
           </a:p>
           <a:p>
@@ -7796,11 +7801,68 @@
             <a:r>
               <a:rPr sz="2000" b="0">
                 <a:solidFill>
+                  <a:srgbClr val="005BAC"/>
+                </a:solidFill>
+                <a:latin typeface="Calibri"/>
+              </a:rPr>
+              <a:t>•  The EKF pre-emptively adapts its trust in GNSS based on predicted degradation:</a:t>
+            </a:r>
+          </a:p>
+          <a:p>
+            <a:pPr algn="l">
+              <a:lnSpc>
+                <a:spcPct val="150000"/>
+              </a:lnSpc>
+              <a:spcAft>
+                <a:spcPts val="1000"/>
+              </a:spcAft>
+            </a:pPr>
+            <a:r>
+              <a:rPr sz="2000" b="0">
+                <a:solidFill>
                   <a:srgbClr val="1A1A1A"/>
                 </a:solidFill>
                 <a:latin typeface="Calibri"/>
               </a:rPr>
-              <a:t>•  Two substantial papers avoid salami-slicing and carry more impact than four thin ones.</a:t>
+              <a:t>•     • When P(DEGRADED) is high → inflate measurement noise R → lean on motion model</a:t>
+            </a:r>
+          </a:p>
+          <a:p>
+            <a:pPr algn="l">
+              <a:lnSpc>
+                <a:spcPct val="150000"/>
+              </a:lnSpc>
+              <a:spcAft>
+                <a:spcPts val="1000"/>
+              </a:spcAft>
+            </a:pPr>
+            <a:r>
+              <a:rPr sz="2000" b="0">
+                <a:solidFill>
+                  <a:srgbClr val="1A1A1A"/>
+                </a:solidFill>
+                <a:latin typeface="Calibri"/>
+              </a:rPr>
+              <a:t>•     • When P(DEGRADED) is low → normal R → use GNSS to correct drift</a:t>
+            </a:r>
+          </a:p>
+          <a:p>
+            <a:pPr algn="l">
+              <a:lnSpc>
+                <a:spcPct val="150000"/>
+              </a:lnSpc>
+              <a:spcAft>
+                <a:spcPts val="1000"/>
+              </a:spcAft>
+            </a:pPr>
+            <a:r>
+              <a:rPr sz="2000" b="0">
+                <a:solidFill>
+                  <a:srgbClr val="1A1A1A"/>
+                </a:solidFill>
+                <a:latin typeface="Calibri"/>
+              </a:rPr>
+              <a:t>•  Result: smoother trajectory during blockage, faster recovery when GNSS returns.</a:t>
             </a:r>
           </a:p>
         </p:txBody>
@@ -7819,7 +7881,7 @@
     <p:bg>
       <p:bgPr>
         <a:solidFill>
-          <a:srgbClr val="003366"/>
+          <a:srgbClr val="F5F8FC"/>
         </a:solidFill>
         <a:effectLst/>
       </p:bgPr>
@@ -7833,62 +7895,20 @@
       <p:grpSpPr/>
       <p:sp>
         <p:nvSpPr>
-          <p:cNvPr id="2" name="TextBox 1"/>
-          <p:cNvSpPr txBox="1"/>
-          <p:nvPr/>
-        </p:nvSpPr>
-        <p:spPr>
-          <a:xfrm>
-            <a:off x="822960" y="2743200"/>
-            <a:ext cx="10515600" cy="1371600"/>
-          </a:xfrm>
-          <a:prstGeom prst="rect">
-            <a:avLst/>
-          </a:prstGeom>
-          <a:noFill/>
-        </p:spPr>
-        <p:txBody>
-          <a:bodyPr wrap="square">
-            <a:spAutoFit/>
-          </a:bodyPr>
-          <a:lstStyle/>
-          <a:p>
-            <a:pPr algn="l">
-              <a:lnSpc>
-                <a:spcPct val="150000"/>
-              </a:lnSpc>
-              <a:spcAft>
-                <a:spcPts val="600"/>
-              </a:spcAft>
-            </a:pPr>
-            <a:r>
-              <a:rPr sz="4600" b="1">
-                <a:solidFill>
-                  <a:srgbClr val="FFFFFF"/>
-                </a:solidFill>
-                <a:latin typeface="Calibri"/>
-              </a:rPr>
-              <a:t>6 · Future Work &amp; Deployment</a:t>
-            </a:r>
-          </a:p>
-        </p:txBody>
-      </p:sp>
-      <p:sp>
-        <p:nvSpPr>
-          <p:cNvPr id="3" name="Rectangle 2"/>
+          <p:cNvPr id="2" name="Rectangle 1"/>
           <p:cNvSpPr/>
           <p:nvPr/>
         </p:nvSpPr>
         <p:spPr>
           <a:xfrm>
-            <a:off x="868680" y="3886200"/>
-            <a:ext cx="2926080" cy="73152"/>
+            <a:off x="548640" y="457200"/>
+            <a:ext cx="164592" cy="822960"/>
           </a:xfrm>
           <a:prstGeom prst="rect">
             <a:avLst/>
           </a:prstGeom>
           <a:solidFill>
-            <a:srgbClr val="00A0E9"/>
+            <a:srgbClr val="005BAC"/>
           </a:solidFill>
           <a:ln>
             <a:noFill/>
@@ -7913,6 +7933,114 @@
           <a:lstStyle/>
           <a:p>
             <a:pPr algn="ctr"/>
+          </a:p>
+        </p:txBody>
+      </p:sp>
+      <p:sp>
+        <p:nvSpPr>
+          <p:cNvPr id="3" name="TextBox 2"/>
+          <p:cNvSpPr txBox="1"/>
+          <p:nvPr/>
+        </p:nvSpPr>
+        <p:spPr>
+          <a:xfrm>
+            <a:off x="868680" y="411480"/>
+            <a:ext cx="10789920" cy="914400"/>
+          </a:xfrm>
+          <a:prstGeom prst="rect">
+            <a:avLst/>
+          </a:prstGeom>
+          <a:noFill/>
+        </p:spPr>
+        <p:txBody>
+          <a:bodyPr wrap="square">
+            <a:spAutoFit/>
+          </a:bodyPr>
+          <a:lstStyle/>
+          <a:p>
+            <a:pPr algn="l">
+              <a:lnSpc>
+                <a:spcPct val="150000"/>
+              </a:lnSpc>
+              <a:spcAft>
+                <a:spcPts val="600"/>
+              </a:spcAft>
+            </a:pPr>
+            <a:r>
+              <a:rPr sz="3400" b="1">
+                <a:solidFill>
+                  <a:srgbClr val="003366"/>
+                </a:solidFill>
+                <a:latin typeface="Calibri"/>
+              </a:rPr>
+              <a:t>EKF Mechanism: Predict-Update Cycle</a:t>
+            </a:r>
+          </a:p>
+        </p:txBody>
+      </p:sp>
+      <p:pic>
+        <p:nvPicPr>
+          <p:cNvPr id="4" name="Picture 3" descr="fig_ekf_mechanism_concept.png"/>
+          <p:cNvPicPr>
+            <a:picLocks noChangeAspect="1"/>
+          </p:cNvPicPr>
+          <p:nvPr/>
+        </p:nvPicPr>
+        <p:blipFill>
+          <a:blip r:embed="rId2"/>
+          <a:stretch>
+            <a:fillRect/>
+          </a:stretch>
+        </p:blipFill>
+        <p:spPr>
+          <a:xfrm>
+            <a:off x="2011680" y="1645920"/>
+            <a:ext cx="7449641" cy="4206240"/>
+          </a:xfrm>
+          <a:prstGeom prst="rect">
+            <a:avLst/>
+          </a:prstGeom>
+        </p:spPr>
+      </p:pic>
+      <p:sp>
+        <p:nvSpPr>
+          <p:cNvPr id="5" name="TextBox 4"/>
+          <p:cNvSpPr txBox="1"/>
+          <p:nvPr/>
+        </p:nvSpPr>
+        <p:spPr>
+          <a:xfrm>
+            <a:off x="868680" y="5943600"/>
+            <a:ext cx="10789920" cy="731520"/>
+          </a:xfrm>
+          <a:prstGeom prst="rect">
+            <a:avLst/>
+          </a:prstGeom>
+          <a:noFill/>
+        </p:spPr>
+        <p:txBody>
+          <a:bodyPr wrap="square">
+            <a:spAutoFit/>
+          </a:bodyPr>
+          <a:lstStyle/>
+          <a:p>
+            <a:pPr algn="l">
+              <a:lnSpc>
+                <a:spcPct val="150000"/>
+              </a:lnSpc>
+              <a:spcAft>
+                <a:spcPts val="600"/>
+              </a:spcAft>
+            </a:pPr>
+            <a:r>
+              <a:rPr sz="1500" b="0">
+                <a:solidFill>
+                  <a:srgbClr val="5A5A5A"/>
+                </a:solidFill>
+                <a:latin typeface="Calibri"/>
+              </a:rPr>
+              <a:t>EKF architecture: GNSS measurement + adaptive noise R + motion model prediction.</a:t>
+            </a:r>
           </a:p>
         </p:txBody>
       </p:sp>
@@ -8022,7 +8150,7 @@
                 </a:solidFill>
                 <a:latin typeface="Calibri"/>
               </a:rPr>
-              <a:t>Real-data EKF: from simulation to deployed navigation</a:t>
+              <a:t>Synthetic Blockage Validation (Option A)</a:t>
             </a:r>
           </a:p>
         </p:txBody>
@@ -8060,11 +8188,30 @@
             <a:r>
               <a:rPr sz="2000" b="0">
                 <a:solidFill>
+                  <a:srgbClr val="005BAC"/>
+                </a:solidFill>
+                <a:latin typeface="Calibri"/>
+              </a:rPr>
+              <a:t>•  Controlled scenario: 300-epoch trajectory with simulated GNSS blockage (epochs 120–180).</a:t>
+            </a:r>
+          </a:p>
+          <a:p>
+            <a:pPr algn="l">
+              <a:lnSpc>
+                <a:spcPct val="150000"/>
+              </a:lnSpc>
+              <a:spcAft>
+                <a:spcPts val="1000"/>
+              </a:spcAft>
+            </a:pPr>
+            <a:r>
+              <a:rPr sz="2000" b="0">
+                <a:solidFill>
                   <a:srgbClr val="1A1A1A"/>
                 </a:solidFill>
                 <a:latin typeface="Calibri"/>
               </a:rPr>
-              <a:t>•  Current: adaptive EKF tested on controlled blockage simulation (33.8% RMSE gain).</a:t>
+              <a:t>•  Predictor (our model) warns from epoch 115, allowing EKF to adapt early (proactive).</a:t>
             </a:r>
           </a:p>
           <a:p>
@@ -8079,11 +8226,30 @@
             <a:r>
               <a:rPr sz="2000" b="0">
                 <a:solidFill>
+                  <a:srgbClr val="005BAC"/>
+                </a:solidFill>
+                <a:latin typeface="Calibri"/>
+              </a:rPr>
+              <a:t>•  Results on blockage segment (epochs 120–180):</a:t>
+            </a:r>
+          </a:p>
+          <a:p>
+            <a:pPr algn="l">
+              <a:lnSpc>
+                <a:spcPct val="150000"/>
+              </a:lnSpc>
+              <a:spcAft>
+                <a:spcPts val="1000"/>
+              </a:spcAft>
+            </a:pPr>
+            <a:r>
+              <a:rPr sz="2000" b="0">
+                <a:solidFill>
                   <a:srgbClr val="1A1A1A"/>
                 </a:solidFill>
                 <a:latin typeface="Calibri"/>
               </a:rPr>
-              <a:t>•  Next: integrate UrbanNav Tokyo ground-truth (reference.csv, cm-level SPAN-INS).</a:t>
+              <a:t>•    • Raw GNSS position RMSE: 54.4 m (noisy)</a:t>
             </a:r>
           </a:p>
           <a:p>
@@ -8102,7 +8268,7 @@
                 </a:solidFill>
                 <a:latin typeface="Calibri"/>
               </a:rPr>
-              <a:t>•  Compute rover single-point positions (RTKLIB SPP from rover.obs), align with reference.</a:t>
+              <a:t>•    • Fixed-R EKF: 45.6 m (standard filter, constant trust)</a:t>
             </a:r>
           </a:p>
           <a:p>
@@ -8121,7 +8287,7 @@
                 </a:solidFill>
                 <a:latin typeface="Calibri"/>
               </a:rPr>
-              <a:t>•  Real-data case study: demonstrate 5–15% RMSE gain on actual urban degradation events.</a:t>
+              <a:t>•    • Adaptive EKF (ours): 36.0 m (-33.8% vs raw GNSS)</a:t>
             </a:r>
           </a:p>
           <a:p>
@@ -8140,7 +8306,7 @@
                 </a:solidFill>
                 <a:latin typeface="Calibri"/>
               </a:rPr>
-              <a:t>•  Phase 2: per-receiver EKF tuning; multi-constellation (GPS+BeiDou+Galileo).</a:t>
+              <a:t>•  Key insight: Prediction-aware filter outperforms fixed filter by 21% on the same GNSS data.</a:t>
             </a:r>
           </a:p>
         </p:txBody>
@@ -8251,21 +8417,83 @@
                 </a:solidFill>
                 <a:latin typeface="Calibri"/>
               </a:rPr>
-              <a:t>Ensemble model deployment &amp; inference pipeline</a:t>
-            </a:r>
-          </a:p>
-        </p:txBody>
-      </p:sp>
-      <p:sp>
-        <p:nvSpPr>
-          <p:cNvPr id="4" name="TextBox 3"/>
+              <a:t>Synthetic Blockage Results</a:t>
+            </a:r>
+          </a:p>
+        </p:txBody>
+      </p:sp>
+      <p:sp>
+        <p:nvSpPr>
+          <p:cNvPr id="4" name="Rectangle 3"/>
+          <p:cNvSpPr/>
+          <p:nvPr/>
+        </p:nvSpPr>
+        <p:spPr>
+          <a:xfrm>
+            <a:off x="2286000" y="1828800"/>
+            <a:ext cx="7589520" cy="3657600"/>
+          </a:xfrm>
+          <a:prstGeom prst="rect">
+            <a:avLst/>
+          </a:prstGeom>
+          <a:solidFill>
+            <a:srgbClr val="E3ECF5"/>
+          </a:solidFill>
+          <a:ln>
+            <a:solidFill>
+              <a:srgbClr val="005BAC"/>
+            </a:solidFill>
+          </a:ln>
+        </p:spPr>
+        <p:style>
+          <a:lnRef idx="1">
+            <a:schemeClr val="accent1"/>
+          </a:lnRef>
+          <a:fillRef idx="3">
+            <a:schemeClr val="accent1"/>
+          </a:fillRef>
+          <a:effectRef idx="2">
+            <a:schemeClr val="accent1"/>
+          </a:effectRef>
+          <a:fontRef idx="minor">
+            <a:schemeClr val="lt1"/>
+          </a:fontRef>
+        </p:style>
+        <p:txBody>
+          <a:bodyPr rtlCol="0" anchor="ctr"/>
+          <a:lstStyle/>
+          <a:p>
+            <a:pPr algn="ctr">
+              <a:lnSpc>
+                <a:spcPct val="150000"/>
+              </a:lnSpc>
+              <a:spcAft>
+                <a:spcPts val="600"/>
+              </a:spcAft>
+            </a:pPr>
+            <a:r>
+              <a:rPr sz="2000" b="1">
+                <a:solidFill>
+                  <a:srgbClr val="005BAC"/>
+                </a:solidFill>
+                <a:latin typeface="Calibri"/>
+              </a:rPr>
+              <a:t>[ INSERT FIGURE ]
+fig20_ekf_option_a_synthetic.png</a:t>
+            </a:r>
+          </a:p>
+        </p:txBody>
+      </p:sp>
+      <p:sp>
+        <p:nvSpPr>
+          <p:cNvPr id="5" name="TextBox 4"/>
           <p:cNvSpPr txBox="1"/>
           <p:nvPr/>
         </p:nvSpPr>
         <p:spPr>
           <a:xfrm>
-            <a:off x="868680" y="1554480"/>
-            <a:ext cx="10607040" cy="4937760"/>
+            <a:off x="868680" y="5943600"/>
+            <a:ext cx="10789920" cy="731520"/>
           </a:xfrm>
           <a:prstGeom prst="rect">
             <a:avLst/>
@@ -8283,93 +8511,17 @@
                 <a:spcPct val="150000"/>
               </a:lnSpc>
               <a:spcAft>
-                <a:spcPts val="1000"/>
-              </a:spcAft>
-            </a:pPr>
-            <a:r>
-              <a:rPr sz="2000" b="0">
-                <a:solidFill>
-                  <a:srgbClr val="1A1A1A"/>
-                </a:solidFill>
-                <a:latin typeface="Calibri"/>
-              </a:rPr>
-              <a:t>•  Save trained XGBoost model (joblib) during training for reproducibility.</a:t>
-            </a:r>
-          </a:p>
-          <a:p>
-            <a:pPr algn="l">
-              <a:lnSpc>
-                <a:spcPct val="150000"/>
-              </a:lnSpc>
-              <a:spcAft>
-                <a:spcPts val="1000"/>
-              </a:spcAft>
-            </a:pPr>
-            <a:r>
-              <a:rPr sz="2000" b="0">
-                <a:solidFill>
-                  <a:srgbClr val="1A1A1A"/>
-                </a:solidFill>
-                <a:latin typeface="Calibri"/>
-              </a:rPr>
-              <a:t>•  inference.py supports --ensemble flag: load DL + XGB, soft-vote probabilities.</a:t>
-            </a:r>
-          </a:p>
-          <a:p>
-            <a:pPr algn="l">
-              <a:lnSpc>
-                <a:spcPct val="150000"/>
-              </a:lnSpc>
-              <a:spcAft>
-                <a:spcPts val="1000"/>
-              </a:spcAft>
-            </a:pPr>
-            <a:r>
-              <a:rPr sz="2000" b="0">
-                <a:solidFill>
-                  <a:srgbClr val="1A1A1A"/>
-                </a:solidFill>
-                <a:latin typeface="Calibri"/>
-              </a:rPr>
-              <a:t>•  End-to-end: NMEA stream → features → P(DEGRADED) +5/15/30s → EKF trajectory.</a:t>
-            </a:r>
-          </a:p>
-          <a:p>
-            <a:pPr algn="l">
-              <a:lnSpc>
-                <a:spcPct val="150000"/>
-              </a:lnSpc>
-              <a:spcAft>
-                <a:spcPts val="1000"/>
-              </a:spcAft>
-            </a:pPr>
-            <a:r>
-              <a:rPr sz="2000" b="0">
-                <a:solidFill>
-                  <a:srgbClr val="1A1A1A"/>
-                </a:solidFill>
-                <a:latin typeface="Calibri"/>
-              </a:rPr>
-              <a:t>•  Real-time capable: 0.045 ms/sample on GPU; 10 Hz stream at &lt;1% CPU.</a:t>
-            </a:r>
-          </a:p>
-          <a:p>
-            <a:pPr algn="l">
-              <a:lnSpc>
-                <a:spcPct val="150000"/>
-              </a:lnSpc>
-              <a:spcAft>
-                <a:spcPts val="1000"/>
-              </a:spcAft>
-            </a:pPr>
-            <a:r>
-              <a:rPr sz="2000" b="0">
-                <a:solidFill>
-                  <a:srgbClr val="005BAC"/>
-                </a:solidFill>
-                <a:latin typeface="Calibri"/>
-              </a:rPr>
-              <a:t>•  Phase 2b: raw per-satellite C/N₀ streams; +60s horizon retraining.</a:t>
+                <a:spcPts val="600"/>
+              </a:spcAft>
+            </a:pPr>
+            <a:r>
+              <a:rPr sz="1500" b="0">
+                <a:solidFill>
+                  <a:srgbClr val="5A5A5A"/>
+                </a:solidFill>
+                <a:latin typeface="Calibri"/>
+              </a:rPr>
+              <a:t>Trajectory during blockage: raw GNSS (noisy) vs. fixed-R EKF vs. adaptive EKF (ours).  (drop in results/figures/fig20_ekf_option_a_synthetic.png)</a:t>
             </a:r>
           </a:p>
         </p:txBody>
@@ -8617,7 +8769,7 @@
     <p:bg>
       <p:bgPr>
         <a:solidFill>
-          <a:srgbClr val="F5F8FC"/>
+          <a:srgbClr val="003366"/>
         </a:solidFill>
         <a:effectLst/>
       </p:bgPr>
@@ -8631,20 +8783,62 @@
       <p:grpSpPr/>
       <p:sp>
         <p:nvSpPr>
-          <p:cNvPr id="2" name="Rectangle 1"/>
+          <p:cNvPr id="2" name="TextBox 1"/>
+          <p:cNvSpPr txBox="1"/>
+          <p:nvPr/>
+        </p:nvSpPr>
+        <p:spPr>
+          <a:xfrm>
+            <a:off x="822960" y="2743200"/>
+            <a:ext cx="10515600" cy="1371600"/>
+          </a:xfrm>
+          <a:prstGeom prst="rect">
+            <a:avLst/>
+          </a:prstGeom>
+          <a:noFill/>
+        </p:spPr>
+        <p:txBody>
+          <a:bodyPr wrap="square">
+            <a:spAutoFit/>
+          </a:bodyPr>
+          <a:lstStyle/>
+          <a:p>
+            <a:pPr algn="l">
+              <a:lnSpc>
+                <a:spcPct val="150000"/>
+              </a:lnSpc>
+              <a:spcAft>
+                <a:spcPts val="600"/>
+              </a:spcAft>
+            </a:pPr>
+            <a:r>
+              <a:rPr sz="4600" b="1">
+                <a:solidFill>
+                  <a:srgbClr val="FFFFFF"/>
+                </a:solidFill>
+                <a:latin typeface="Calibri"/>
+              </a:rPr>
+              <a:t>6 · Roadmap &amp; Deliverables</a:t>
+            </a:r>
+          </a:p>
+        </p:txBody>
+      </p:sp>
+      <p:sp>
+        <p:nvSpPr>
+          <p:cNvPr id="3" name="Rectangle 2"/>
           <p:cNvSpPr/>
           <p:nvPr/>
         </p:nvSpPr>
         <p:spPr>
           <a:xfrm>
-            <a:off x="548640" y="457200"/>
-            <a:ext cx="164592" cy="822960"/>
+            <a:off x="868680" y="3886200"/>
+            <a:ext cx="2926080" cy="73152"/>
           </a:xfrm>
           <a:prstGeom prst="rect">
             <a:avLst/>
           </a:prstGeom>
           <a:solidFill>
-            <a:srgbClr val="005BAC"/>
+            <a:srgbClr val="00A0E9"/>
           </a:solidFill>
           <a:ln>
             <a:noFill/>
@@ -8669,166 +8863,6 @@
           <a:lstStyle/>
           <a:p>
             <a:pPr algn="ctr"/>
-          </a:p>
-        </p:txBody>
-      </p:sp>
-      <p:sp>
-        <p:nvSpPr>
-          <p:cNvPr id="3" name="TextBox 2"/>
-          <p:cNvSpPr txBox="1"/>
-          <p:nvPr/>
-        </p:nvSpPr>
-        <p:spPr>
-          <a:xfrm>
-            <a:off x="868680" y="411480"/>
-            <a:ext cx="10789920" cy="914400"/>
-          </a:xfrm>
-          <a:prstGeom prst="rect">
-            <a:avLst/>
-          </a:prstGeom>
-          <a:noFill/>
-        </p:spPr>
-        <p:txBody>
-          <a:bodyPr wrap="square">
-            <a:spAutoFit/>
-          </a:bodyPr>
-          <a:lstStyle/>
-          <a:p>
-            <a:pPr algn="l">
-              <a:lnSpc>
-                <a:spcPct val="150000"/>
-              </a:lnSpc>
-              <a:spcAft>
-                <a:spcPts val="600"/>
-              </a:spcAft>
-            </a:pPr>
-            <a:r>
-              <a:rPr sz="3400" b="1">
-                <a:solidFill>
-                  <a:srgbClr val="003366"/>
-                </a:solidFill>
-                <a:latin typeface="Calibri"/>
-              </a:rPr>
-              <a:t>Web dashboard (Next.js + FastAPI)</a:t>
-            </a:r>
-          </a:p>
-        </p:txBody>
-      </p:sp>
-      <p:sp>
-        <p:nvSpPr>
-          <p:cNvPr id="4" name="TextBox 3"/>
-          <p:cNvSpPr txBox="1"/>
-          <p:nvPr/>
-        </p:nvSpPr>
-        <p:spPr>
-          <a:xfrm>
-            <a:off x="868680" y="1554480"/>
-            <a:ext cx="10607040" cy="4937760"/>
-          </a:xfrm>
-          <a:prstGeom prst="rect">
-            <a:avLst/>
-          </a:prstGeom>
-          <a:noFill/>
-        </p:spPr>
-        <p:txBody>
-          <a:bodyPr wrap="square">
-            <a:spAutoFit/>
-          </a:bodyPr>
-          <a:lstStyle/>
-          <a:p>
-            <a:pPr algn="l">
-              <a:lnSpc>
-                <a:spcPct val="150000"/>
-              </a:lnSpc>
-              <a:spcAft>
-                <a:spcPts val="1000"/>
-              </a:spcAft>
-            </a:pPr>
-            <a:r>
-              <a:rPr sz="2000" b="0">
-                <a:solidFill>
-                  <a:srgbClr val="1A1A1A"/>
-                </a:solidFill>
-                <a:latin typeface="Calibri"/>
-              </a:rPr>
-              <a:t>•  Real-time monitor: C/N₀, DOP, sat count + live 3-horizon prediction bars.</a:t>
-            </a:r>
-          </a:p>
-          <a:p>
-            <a:pPr algn="l">
-              <a:lnSpc>
-                <a:spcPct val="150000"/>
-              </a:lnSpc>
-              <a:spcAft>
-                <a:spcPts val="1000"/>
-              </a:spcAft>
-            </a:pPr>
-            <a:r>
-              <a:rPr sz="2000" b="0">
-                <a:solidFill>
-                  <a:srgbClr val="1A1A1A"/>
-                </a:solidFill>
-                <a:latin typeface="Calibri"/>
-              </a:rPr>
-              <a:t>•  Route map (Mapbox): colour-coded predicted signal quality along the planned path.</a:t>
-            </a:r>
-          </a:p>
-          <a:p>
-            <a:pPr algn="l">
-              <a:lnSpc>
-                <a:spcPct val="150000"/>
-              </a:lnSpc>
-              <a:spcAft>
-                <a:spcPts val="1000"/>
-              </a:spcAft>
-            </a:pPr>
-            <a:r>
-              <a:rPr sz="2000" b="0">
-                <a:solidFill>
-                  <a:srgbClr val="1A1A1A"/>
-                </a:solidFill>
-                <a:latin typeface="Calibri"/>
-              </a:rPr>
-              <a:t>•  Prediction timeline with lead-time annotations; attention heatmap for interpretability.</a:t>
-            </a:r>
-          </a:p>
-          <a:p>
-            <a:pPr algn="l">
-              <a:lnSpc>
-                <a:spcPct val="150000"/>
-              </a:lnSpc>
-              <a:spcAft>
-                <a:spcPts val="1000"/>
-              </a:spcAft>
-            </a:pPr>
-            <a:r>
-              <a:rPr sz="2000" b="0">
-                <a:solidFill>
-                  <a:srgbClr val="1A1A1A"/>
-                </a:solidFill>
-                <a:latin typeface="Calibri"/>
-              </a:rPr>
-              <a:t>•  DL-vs-baseline comparison; dataset explorer (149k epochs); metrics/performance board.</a:t>
-            </a:r>
-          </a:p>
-          <a:p>
-            <a:pPr algn="l">
-              <a:lnSpc>
-                <a:spcPct val="150000"/>
-              </a:lnSpc>
-              <a:spcAft>
-                <a:spcPts val="1000"/>
-              </a:spcAft>
-            </a:pPr>
-            <a:r>
-              <a:rPr sz="2000" b="0">
-                <a:solidFill>
-                  <a:srgbClr val="005BAC"/>
-                </a:solidFill>
-                <a:latin typeface="Calibri"/>
-              </a:rPr>
-              <a:t>•  Phase 2: integrate actual vehicle IMU; Kalman-filter fusion visualization.</a:t>
-            </a:r>
           </a:p>
         </p:txBody>
       </p:sp>
@@ -8938,7 +8972,7 @@
                 </a:solidFill>
                 <a:latin typeface="Calibri"/>
               </a:rPr>
-              <a:t>Publication &amp; reproducibility</a:t>
+              <a:t>Publication plan — 2 papers + 1 conference</a:t>
             </a:r>
           </a:p>
         </p:txBody>
@@ -8980,7 +9014,7 @@
                 </a:solidFill>
                 <a:latin typeface="Calibri"/>
               </a:rPr>
-              <a:t>•  Paper A (GPS Solutions, Q1): method + multi-horizon + cross-receiver + cross-city.</a:t>
+              <a:t>•  Paper A (GPS Solutions, Q1): method + multi-horizon + cross-receiver + cross-city + EKF.</a:t>
             </a:r>
           </a:p>
           <a:p>
@@ -8999,7 +9033,7 @@
                 </a:solidFill>
                 <a:latin typeface="Calibri"/>
               </a:rPr>
-              <a:t>•  Paper B (Journal of Navigation): model comparison → ensemble selection → EKF integration.</a:t>
+              <a:t>•  Paper B (Scientific Data / Data in Brief): the benchmark / dataset descriptor.</a:t>
             </a:r>
           </a:p>
           <a:p>
@@ -9018,7 +9052,7 @@
                 </a:solidFill>
                 <a:latin typeface="Calibri"/>
               </a:rPr>
-              <a:t>•  Conference (ION GNSS+ 2026): cross-city generalization result as a systems paper.</a:t>
+              <a:t>•  Conference (ION GNSS+ 2026): cross-city result as a short paper, later extended.</a:t>
             </a:r>
           </a:p>
           <a:p>
@@ -9037,26 +9071,7 @@
                 </a:solidFill>
                 <a:latin typeface="Calibri"/>
               </a:rPr>
-              <a:t>•  Data + code release: GitHub + Zenodo (reproducible; citable DOI).</a:t>
-            </a:r>
-          </a:p>
-          <a:p>
-            <a:pPr algn="l">
-              <a:lnSpc>
-                <a:spcPct val="150000"/>
-              </a:lnSpc>
-              <a:spcAft>
-                <a:spcPts val="1000"/>
-              </a:spcAft>
-            </a:pPr>
-            <a:r>
-              <a:rPr sz="2000" b="0">
-                <a:solidFill>
-                  <a:srgbClr val="1A1A1A"/>
-                </a:solidFill>
-                <a:latin typeface="Calibri"/>
-              </a:rPr>
-              <a:t>•  All results / figures / models in results/ (zipped &amp; versioned).</a:t>
+              <a:t>•  Two substantial papers avoid salami-slicing and carry more impact than four thin ones.</a:t>
             </a:r>
           </a:p>
         </p:txBody>
@@ -9070,6 +9085,1147 @@
 </file>
 
 <file path=ppt/slides/slide32.xml><?xml version="1.0" encoding="utf-8"?>
+<p:sld xmlns:a="http://schemas.openxmlformats.org/drawingml/2006/main" xmlns:p="http://schemas.openxmlformats.org/presentationml/2006/main" xmlns:r="http://schemas.openxmlformats.org/officeDocument/2006/relationships">
+  <p:cSld>
+    <p:bg>
+      <p:bgPr>
+        <a:solidFill>
+          <a:srgbClr val="003366"/>
+        </a:solidFill>
+        <a:effectLst/>
+      </p:bgPr>
+    </p:bg>
+    <p:spTree>
+      <p:nvGrpSpPr>
+        <p:cNvPr id="1" name=""/>
+        <p:cNvGrpSpPr/>
+        <p:nvPr/>
+      </p:nvGrpSpPr>
+      <p:grpSpPr/>
+      <p:sp>
+        <p:nvSpPr>
+          <p:cNvPr id="2" name="TextBox 1"/>
+          <p:cNvSpPr txBox="1"/>
+          <p:nvPr/>
+        </p:nvSpPr>
+        <p:spPr>
+          <a:xfrm>
+            <a:off x="822960" y="2743200"/>
+            <a:ext cx="10515600" cy="1371600"/>
+          </a:xfrm>
+          <a:prstGeom prst="rect">
+            <a:avLst/>
+          </a:prstGeom>
+          <a:noFill/>
+        </p:spPr>
+        <p:txBody>
+          <a:bodyPr wrap="square">
+            <a:spAutoFit/>
+          </a:bodyPr>
+          <a:lstStyle/>
+          <a:p>
+            <a:pPr algn="l">
+              <a:lnSpc>
+                <a:spcPct val="150000"/>
+              </a:lnSpc>
+              <a:spcAft>
+                <a:spcPts val="600"/>
+              </a:spcAft>
+            </a:pPr>
+            <a:r>
+              <a:rPr sz="4600" b="1">
+                <a:solidFill>
+                  <a:srgbClr val="FFFFFF"/>
+                </a:solidFill>
+                <a:latin typeface="Calibri"/>
+              </a:rPr>
+              <a:t>6 · Future Work &amp; Deployment</a:t>
+            </a:r>
+          </a:p>
+        </p:txBody>
+      </p:sp>
+      <p:sp>
+        <p:nvSpPr>
+          <p:cNvPr id="3" name="Rectangle 2"/>
+          <p:cNvSpPr/>
+          <p:nvPr/>
+        </p:nvSpPr>
+        <p:spPr>
+          <a:xfrm>
+            <a:off x="868680" y="3886200"/>
+            <a:ext cx="2926080" cy="73152"/>
+          </a:xfrm>
+          <a:prstGeom prst="rect">
+            <a:avLst/>
+          </a:prstGeom>
+          <a:solidFill>
+            <a:srgbClr val="00A0E9"/>
+          </a:solidFill>
+          <a:ln>
+            <a:noFill/>
+          </a:ln>
+        </p:spPr>
+        <p:style>
+          <a:lnRef idx="1">
+            <a:schemeClr val="accent1"/>
+          </a:lnRef>
+          <a:fillRef idx="3">
+            <a:schemeClr val="accent1"/>
+          </a:fillRef>
+          <a:effectRef idx="2">
+            <a:schemeClr val="accent1"/>
+          </a:effectRef>
+          <a:fontRef idx="minor">
+            <a:schemeClr val="lt1"/>
+          </a:fontRef>
+        </p:style>
+        <p:txBody>
+          <a:bodyPr rtlCol="0" anchor="ctr"/>
+          <a:lstStyle/>
+          <a:p>
+            <a:pPr algn="ctr"/>
+          </a:p>
+        </p:txBody>
+      </p:sp>
+    </p:spTree>
+  </p:cSld>
+  <p:clrMapOvr>
+    <a:masterClrMapping/>
+  </p:clrMapOvr>
+</p:sld>
+</file>
+
+<file path=ppt/slides/slide33.xml><?xml version="1.0" encoding="utf-8"?>
+<p:sld xmlns:a="http://schemas.openxmlformats.org/drawingml/2006/main" xmlns:p="http://schemas.openxmlformats.org/presentationml/2006/main" xmlns:r="http://schemas.openxmlformats.org/officeDocument/2006/relationships">
+  <p:cSld>
+    <p:bg>
+      <p:bgPr>
+        <a:solidFill>
+          <a:srgbClr val="F5F8FC"/>
+        </a:solidFill>
+        <a:effectLst/>
+      </p:bgPr>
+    </p:bg>
+    <p:spTree>
+      <p:nvGrpSpPr>
+        <p:cNvPr id="1" name=""/>
+        <p:cNvGrpSpPr/>
+        <p:nvPr/>
+      </p:nvGrpSpPr>
+      <p:grpSpPr/>
+      <p:sp>
+        <p:nvSpPr>
+          <p:cNvPr id="2" name="Rectangle 1"/>
+          <p:cNvSpPr/>
+          <p:nvPr/>
+        </p:nvSpPr>
+        <p:spPr>
+          <a:xfrm>
+            <a:off x="548640" y="457200"/>
+            <a:ext cx="164592" cy="822960"/>
+          </a:xfrm>
+          <a:prstGeom prst="rect">
+            <a:avLst/>
+          </a:prstGeom>
+          <a:solidFill>
+            <a:srgbClr val="005BAC"/>
+          </a:solidFill>
+          <a:ln>
+            <a:noFill/>
+          </a:ln>
+        </p:spPr>
+        <p:style>
+          <a:lnRef idx="1">
+            <a:schemeClr val="accent1"/>
+          </a:lnRef>
+          <a:fillRef idx="3">
+            <a:schemeClr val="accent1"/>
+          </a:fillRef>
+          <a:effectRef idx="2">
+            <a:schemeClr val="accent1"/>
+          </a:effectRef>
+          <a:fontRef idx="minor">
+            <a:schemeClr val="lt1"/>
+          </a:fontRef>
+        </p:style>
+        <p:txBody>
+          <a:bodyPr rtlCol="0" anchor="ctr"/>
+          <a:lstStyle/>
+          <a:p>
+            <a:pPr algn="ctr"/>
+          </a:p>
+        </p:txBody>
+      </p:sp>
+      <p:sp>
+        <p:nvSpPr>
+          <p:cNvPr id="3" name="TextBox 2"/>
+          <p:cNvSpPr txBox="1"/>
+          <p:nvPr/>
+        </p:nvSpPr>
+        <p:spPr>
+          <a:xfrm>
+            <a:off x="868680" y="411480"/>
+            <a:ext cx="10789920" cy="914400"/>
+          </a:xfrm>
+          <a:prstGeom prst="rect">
+            <a:avLst/>
+          </a:prstGeom>
+          <a:noFill/>
+        </p:spPr>
+        <p:txBody>
+          <a:bodyPr wrap="square">
+            <a:spAutoFit/>
+          </a:bodyPr>
+          <a:lstStyle/>
+          <a:p>
+            <a:pPr algn="l">
+              <a:lnSpc>
+                <a:spcPct val="150000"/>
+              </a:lnSpc>
+              <a:spcAft>
+                <a:spcPts val="600"/>
+              </a:spcAft>
+            </a:pPr>
+            <a:r>
+              <a:rPr sz="3400" b="1">
+                <a:solidFill>
+                  <a:srgbClr val="003366"/>
+                </a:solidFill>
+                <a:latin typeface="Calibri"/>
+              </a:rPr>
+              <a:t>Real-data EKF: from simulation to deployed navigation (Option B, Phase 2a)</a:t>
+            </a:r>
+          </a:p>
+        </p:txBody>
+      </p:sp>
+      <p:sp>
+        <p:nvSpPr>
+          <p:cNvPr id="4" name="TextBox 3"/>
+          <p:cNvSpPr txBox="1"/>
+          <p:nvPr/>
+        </p:nvSpPr>
+        <p:spPr>
+          <a:xfrm>
+            <a:off x="868680" y="1554480"/>
+            <a:ext cx="10607040" cy="4937760"/>
+          </a:xfrm>
+          <a:prstGeom prst="rect">
+            <a:avLst/>
+          </a:prstGeom>
+          <a:noFill/>
+        </p:spPr>
+        <p:txBody>
+          <a:bodyPr wrap="square">
+            <a:spAutoFit/>
+          </a:bodyPr>
+          <a:lstStyle/>
+          <a:p>
+            <a:pPr algn="l">
+              <a:lnSpc>
+                <a:spcPct val="150000"/>
+              </a:lnSpc>
+              <a:spcAft>
+                <a:spcPts val="1000"/>
+              </a:spcAft>
+            </a:pPr>
+            <a:r>
+              <a:rPr sz="2000" b="0">
+                <a:solidFill>
+                  <a:srgbClr val="005BAC"/>
+                </a:solidFill>
+                <a:latin typeface="Calibri"/>
+              </a:rPr>
+              <a:t>•  Why UrbanNav Tokyo for validation?</a:t>
+            </a:r>
+          </a:p>
+          <a:p>
+            <a:pPr algn="l">
+              <a:lnSpc>
+                <a:spcPct val="150000"/>
+              </a:lnSpc>
+              <a:spcAft>
+                <a:spcPts val="1000"/>
+              </a:spcAft>
+            </a:pPr>
+            <a:r>
+              <a:rPr sz="2000" b="0">
+                <a:solidFill>
+                  <a:srgbClr val="1A1A1A"/>
+                </a:solidFill>
+                <a:latin typeface="Calibri"/>
+              </a:rPr>
+              <a:t>•    • UrbanNav provides cm-level ground truth (SPAN-INS post-processed trajectory in reference.csv)</a:t>
+            </a:r>
+          </a:p>
+          <a:p>
+            <a:pPr algn="l">
+              <a:lnSpc>
+                <a:spcPct val="150000"/>
+              </a:lnSpc>
+              <a:spcAft>
+                <a:spcPts val="1000"/>
+              </a:spcAft>
+            </a:pPr>
+            <a:r>
+              <a:rPr sz="2000" b="0">
+                <a:solidFill>
+                  <a:srgbClr val="1A1A1A"/>
+                </a:solidFill>
+                <a:latin typeface="Calibri"/>
+              </a:rPr>
+              <a:t>•    • Real GNSS data with actual urban blockage events (not synthetic)</a:t>
+            </a:r>
+          </a:p>
+          <a:p>
+            <a:pPr algn="l">
+              <a:lnSpc>
+                <a:spcPct val="150000"/>
+              </a:lnSpc>
+              <a:spcAft>
+                <a:spcPts val="1000"/>
+              </a:spcAft>
+            </a:pPr>
+            <a:r>
+              <a:rPr sz="2000" b="0">
+                <a:solidFill>
+                  <a:srgbClr val="1A1A1A"/>
+                </a:solidFill>
+                <a:latin typeface="Calibri"/>
+              </a:rPr>
+              <a:t>•    • Real IMU data (accelerometer + gyro) for 9-state EKF integration</a:t>
+            </a:r>
+          </a:p>
+          <a:p>
+            <a:pPr algn="l">
+              <a:lnSpc>
+                <a:spcPct val="150000"/>
+              </a:lnSpc>
+              <a:spcAft>
+                <a:spcPts val="1000"/>
+              </a:spcAft>
+            </a:pPr>
+            <a:r>
+              <a:rPr sz="2000" b="0">
+                <a:solidFill>
+                  <a:srgbClr val="1A1A1A"/>
+                </a:solidFill>
+                <a:latin typeface="Calibri"/>
+              </a:rPr>
+              <a:t>•    • Unseen city (cross-city test) — same as our model validation</a:t>
+            </a:r>
+          </a:p>
+          <a:p>
+            <a:pPr algn="l">
+              <a:lnSpc>
+                <a:spcPct val="150000"/>
+              </a:lnSpc>
+              <a:spcAft>
+                <a:spcPts val="1000"/>
+              </a:spcAft>
+            </a:pPr>
+            <a:r>
+              <a:rPr sz="2000" b="0">
+                <a:solidFill>
+                  <a:srgbClr val="005BAC"/>
+                </a:solidFill>
+                <a:latin typeface="Calibri"/>
+              </a:rPr>
+              <a:t>•  What we'll do:</a:t>
+            </a:r>
+          </a:p>
+          <a:p>
+            <a:pPr algn="l">
+              <a:lnSpc>
+                <a:spcPct val="150000"/>
+              </a:lnSpc>
+              <a:spcAft>
+                <a:spcPts val="1000"/>
+              </a:spcAft>
+            </a:pPr>
+            <a:r>
+              <a:rPr sz="2000" b="0">
+                <a:solidFill>
+                  <a:srgbClr val="1A1A1A"/>
+                </a:solidFill>
+                <a:latin typeface="Calibri"/>
+              </a:rPr>
+              <a:t>•    1. Parse rover GNSS (RINEX) → single-point positions</a:t>
+            </a:r>
+          </a:p>
+          <a:p>
+            <a:pPr algn="l">
+              <a:lnSpc>
+                <a:spcPct val="150000"/>
+              </a:lnSpc>
+              <a:spcAft>
+                <a:spcPts val="1000"/>
+              </a:spcAft>
+            </a:pPr>
+            <a:r>
+              <a:rPr sz="2000" b="0">
+                <a:solidFill>
+                  <a:srgbClr val="1A1A1A"/>
+                </a:solidFill>
+                <a:latin typeface="Calibri"/>
+              </a:rPr>
+              <a:t>•    2. Parse IMU (imu.csv) and reference trajectory (reference.csv)</a:t>
+            </a:r>
+          </a:p>
+          <a:p>
+            <a:pPr algn="l">
+              <a:lnSpc>
+                <a:spcPct val="150000"/>
+              </a:lnSpc>
+              <a:spcAft>
+                <a:spcPts val="1000"/>
+              </a:spcAft>
+            </a:pPr>
+            <a:r>
+              <a:rPr sz="2000" b="0">
+                <a:solidFill>
+                  <a:srgbClr val="1A1A1A"/>
+                </a:solidFill>
+                <a:latin typeface="Calibri"/>
+              </a:rPr>
+              <a:t>•    3. Run 9-state EKF (IMU-driven prediction, GNSS update) with adaptive R</a:t>
+            </a:r>
+          </a:p>
+          <a:p>
+            <a:pPr algn="l">
+              <a:lnSpc>
+                <a:spcPct val="150000"/>
+              </a:lnSpc>
+              <a:spcAft>
+                <a:spcPts val="1000"/>
+              </a:spcAft>
+            </a:pPr>
+            <a:r>
+              <a:rPr sz="2000" b="0">
+                <a:solidFill>
+                  <a:srgbClr val="1A1A1A"/>
+                </a:solidFill>
+                <a:latin typeface="Calibri"/>
+              </a:rPr>
+              <a:t>•    4. Compute real RMSE gain (expected: 15–30% during actual blockage)</a:t>
+            </a:r>
+          </a:p>
+          <a:p>
+            <a:pPr algn="l">
+              <a:lnSpc>
+                <a:spcPct val="150000"/>
+              </a:lnSpc>
+              <a:spcAft>
+                <a:spcPts val="1000"/>
+              </a:spcAft>
+            </a:pPr>
+            <a:r>
+              <a:rPr sz="2000" b="0">
+                <a:solidFill>
+                  <a:srgbClr val="1A1A1A"/>
+                </a:solidFill>
+                <a:latin typeface="Calibri"/>
+              </a:rPr>
+              <a:t>•  Result: honest real-world validation (no synthetic assumptions).</a:t>
+            </a:r>
+          </a:p>
+        </p:txBody>
+      </p:sp>
+    </p:spTree>
+  </p:cSld>
+  <p:clrMapOvr>
+    <a:masterClrMapping/>
+  </p:clrMapOvr>
+</p:sld>
+</file>
+
+<file path=ppt/slides/slide34.xml><?xml version="1.0" encoding="utf-8"?>
+<p:sld xmlns:a="http://schemas.openxmlformats.org/drawingml/2006/main" xmlns:p="http://schemas.openxmlformats.org/presentationml/2006/main" xmlns:r="http://schemas.openxmlformats.org/officeDocument/2006/relationships">
+  <p:cSld>
+    <p:bg>
+      <p:bgPr>
+        <a:solidFill>
+          <a:srgbClr val="F5F8FC"/>
+        </a:solidFill>
+        <a:effectLst/>
+      </p:bgPr>
+    </p:bg>
+    <p:spTree>
+      <p:nvGrpSpPr>
+        <p:cNvPr id="1" name=""/>
+        <p:cNvGrpSpPr/>
+        <p:nvPr/>
+      </p:nvGrpSpPr>
+      <p:grpSpPr/>
+      <p:sp>
+        <p:nvSpPr>
+          <p:cNvPr id="2" name="Rectangle 1"/>
+          <p:cNvSpPr/>
+          <p:nvPr/>
+        </p:nvSpPr>
+        <p:spPr>
+          <a:xfrm>
+            <a:off x="548640" y="457200"/>
+            <a:ext cx="164592" cy="822960"/>
+          </a:xfrm>
+          <a:prstGeom prst="rect">
+            <a:avLst/>
+          </a:prstGeom>
+          <a:solidFill>
+            <a:srgbClr val="005BAC"/>
+          </a:solidFill>
+          <a:ln>
+            <a:noFill/>
+          </a:ln>
+        </p:spPr>
+        <p:style>
+          <a:lnRef idx="1">
+            <a:schemeClr val="accent1"/>
+          </a:lnRef>
+          <a:fillRef idx="3">
+            <a:schemeClr val="accent1"/>
+          </a:fillRef>
+          <a:effectRef idx="2">
+            <a:schemeClr val="accent1"/>
+          </a:effectRef>
+          <a:fontRef idx="minor">
+            <a:schemeClr val="lt1"/>
+          </a:fontRef>
+        </p:style>
+        <p:txBody>
+          <a:bodyPr rtlCol="0" anchor="ctr"/>
+          <a:lstStyle/>
+          <a:p>
+            <a:pPr algn="ctr"/>
+          </a:p>
+        </p:txBody>
+      </p:sp>
+      <p:sp>
+        <p:nvSpPr>
+          <p:cNvPr id="3" name="TextBox 2"/>
+          <p:cNvSpPr txBox="1"/>
+          <p:nvPr/>
+        </p:nvSpPr>
+        <p:spPr>
+          <a:xfrm>
+            <a:off x="868680" y="411480"/>
+            <a:ext cx="10789920" cy="914400"/>
+          </a:xfrm>
+          <a:prstGeom prst="rect">
+            <a:avLst/>
+          </a:prstGeom>
+          <a:noFill/>
+        </p:spPr>
+        <p:txBody>
+          <a:bodyPr wrap="square">
+            <a:spAutoFit/>
+          </a:bodyPr>
+          <a:lstStyle/>
+          <a:p>
+            <a:pPr algn="l">
+              <a:lnSpc>
+                <a:spcPct val="150000"/>
+              </a:lnSpc>
+              <a:spcAft>
+                <a:spcPts val="600"/>
+              </a:spcAft>
+            </a:pPr>
+            <a:r>
+              <a:rPr sz="3400" b="1">
+                <a:solidFill>
+                  <a:srgbClr val="003366"/>
+                </a:solidFill>
+                <a:latin typeface="Calibri"/>
+              </a:rPr>
+              <a:t>Ensemble model deployment &amp; inference pipeline</a:t>
+            </a:r>
+          </a:p>
+        </p:txBody>
+      </p:sp>
+      <p:sp>
+        <p:nvSpPr>
+          <p:cNvPr id="4" name="TextBox 3"/>
+          <p:cNvSpPr txBox="1"/>
+          <p:nvPr/>
+        </p:nvSpPr>
+        <p:spPr>
+          <a:xfrm>
+            <a:off x="868680" y="1554480"/>
+            <a:ext cx="10607040" cy="4937760"/>
+          </a:xfrm>
+          <a:prstGeom prst="rect">
+            <a:avLst/>
+          </a:prstGeom>
+          <a:noFill/>
+        </p:spPr>
+        <p:txBody>
+          <a:bodyPr wrap="square">
+            <a:spAutoFit/>
+          </a:bodyPr>
+          <a:lstStyle/>
+          <a:p>
+            <a:pPr algn="l">
+              <a:lnSpc>
+                <a:spcPct val="150000"/>
+              </a:lnSpc>
+              <a:spcAft>
+                <a:spcPts val="1000"/>
+              </a:spcAft>
+            </a:pPr>
+            <a:r>
+              <a:rPr sz="2000" b="0">
+                <a:solidFill>
+                  <a:srgbClr val="1A1A1A"/>
+                </a:solidFill>
+                <a:latin typeface="Calibri"/>
+              </a:rPr>
+              <a:t>•  Save trained XGBoost model (joblib) during training for reproducibility.</a:t>
+            </a:r>
+          </a:p>
+          <a:p>
+            <a:pPr algn="l">
+              <a:lnSpc>
+                <a:spcPct val="150000"/>
+              </a:lnSpc>
+              <a:spcAft>
+                <a:spcPts val="1000"/>
+              </a:spcAft>
+            </a:pPr>
+            <a:r>
+              <a:rPr sz="2000" b="0">
+                <a:solidFill>
+                  <a:srgbClr val="1A1A1A"/>
+                </a:solidFill>
+                <a:latin typeface="Calibri"/>
+              </a:rPr>
+              <a:t>•  inference.py supports --ensemble flag: load DL + XGB, soft-vote probabilities.</a:t>
+            </a:r>
+          </a:p>
+          <a:p>
+            <a:pPr algn="l">
+              <a:lnSpc>
+                <a:spcPct val="150000"/>
+              </a:lnSpc>
+              <a:spcAft>
+                <a:spcPts val="1000"/>
+              </a:spcAft>
+            </a:pPr>
+            <a:r>
+              <a:rPr sz="2000" b="0">
+                <a:solidFill>
+                  <a:srgbClr val="1A1A1A"/>
+                </a:solidFill>
+                <a:latin typeface="Calibri"/>
+              </a:rPr>
+              <a:t>•  End-to-end: NMEA stream → features → P(DEGRADED) +5/15/30s → EKF trajectory.</a:t>
+            </a:r>
+          </a:p>
+          <a:p>
+            <a:pPr algn="l">
+              <a:lnSpc>
+                <a:spcPct val="150000"/>
+              </a:lnSpc>
+              <a:spcAft>
+                <a:spcPts val="1000"/>
+              </a:spcAft>
+            </a:pPr>
+            <a:r>
+              <a:rPr sz="2000" b="0">
+                <a:solidFill>
+                  <a:srgbClr val="1A1A1A"/>
+                </a:solidFill>
+                <a:latin typeface="Calibri"/>
+              </a:rPr>
+              <a:t>•  Real-time capable: 0.045 ms/sample on GPU; 10 Hz stream at &lt;1% CPU.</a:t>
+            </a:r>
+          </a:p>
+          <a:p>
+            <a:pPr algn="l">
+              <a:lnSpc>
+                <a:spcPct val="150000"/>
+              </a:lnSpc>
+              <a:spcAft>
+                <a:spcPts val="1000"/>
+              </a:spcAft>
+            </a:pPr>
+            <a:r>
+              <a:rPr sz="2000" b="0">
+                <a:solidFill>
+                  <a:srgbClr val="005BAC"/>
+                </a:solidFill>
+                <a:latin typeface="Calibri"/>
+              </a:rPr>
+              <a:t>•  Phase 2b: raw per-satellite C/N₀ streams; +60s horizon retraining.</a:t>
+            </a:r>
+          </a:p>
+        </p:txBody>
+      </p:sp>
+    </p:spTree>
+  </p:cSld>
+  <p:clrMapOvr>
+    <a:masterClrMapping/>
+  </p:clrMapOvr>
+</p:sld>
+</file>
+
+<file path=ppt/slides/slide35.xml><?xml version="1.0" encoding="utf-8"?>
+<p:sld xmlns:a="http://schemas.openxmlformats.org/drawingml/2006/main" xmlns:p="http://schemas.openxmlformats.org/presentationml/2006/main" xmlns:r="http://schemas.openxmlformats.org/officeDocument/2006/relationships">
+  <p:cSld>
+    <p:bg>
+      <p:bgPr>
+        <a:solidFill>
+          <a:srgbClr val="F5F8FC"/>
+        </a:solidFill>
+        <a:effectLst/>
+      </p:bgPr>
+    </p:bg>
+    <p:spTree>
+      <p:nvGrpSpPr>
+        <p:cNvPr id="1" name=""/>
+        <p:cNvGrpSpPr/>
+        <p:nvPr/>
+      </p:nvGrpSpPr>
+      <p:grpSpPr/>
+      <p:sp>
+        <p:nvSpPr>
+          <p:cNvPr id="2" name="Rectangle 1"/>
+          <p:cNvSpPr/>
+          <p:nvPr/>
+        </p:nvSpPr>
+        <p:spPr>
+          <a:xfrm>
+            <a:off x="548640" y="457200"/>
+            <a:ext cx="164592" cy="822960"/>
+          </a:xfrm>
+          <a:prstGeom prst="rect">
+            <a:avLst/>
+          </a:prstGeom>
+          <a:solidFill>
+            <a:srgbClr val="005BAC"/>
+          </a:solidFill>
+          <a:ln>
+            <a:noFill/>
+          </a:ln>
+        </p:spPr>
+        <p:style>
+          <a:lnRef idx="1">
+            <a:schemeClr val="accent1"/>
+          </a:lnRef>
+          <a:fillRef idx="3">
+            <a:schemeClr val="accent1"/>
+          </a:fillRef>
+          <a:effectRef idx="2">
+            <a:schemeClr val="accent1"/>
+          </a:effectRef>
+          <a:fontRef idx="minor">
+            <a:schemeClr val="lt1"/>
+          </a:fontRef>
+        </p:style>
+        <p:txBody>
+          <a:bodyPr rtlCol="0" anchor="ctr"/>
+          <a:lstStyle/>
+          <a:p>
+            <a:pPr algn="ctr"/>
+          </a:p>
+        </p:txBody>
+      </p:sp>
+      <p:sp>
+        <p:nvSpPr>
+          <p:cNvPr id="3" name="TextBox 2"/>
+          <p:cNvSpPr txBox="1"/>
+          <p:nvPr/>
+        </p:nvSpPr>
+        <p:spPr>
+          <a:xfrm>
+            <a:off x="868680" y="411480"/>
+            <a:ext cx="10789920" cy="914400"/>
+          </a:xfrm>
+          <a:prstGeom prst="rect">
+            <a:avLst/>
+          </a:prstGeom>
+          <a:noFill/>
+        </p:spPr>
+        <p:txBody>
+          <a:bodyPr wrap="square">
+            <a:spAutoFit/>
+          </a:bodyPr>
+          <a:lstStyle/>
+          <a:p>
+            <a:pPr algn="l">
+              <a:lnSpc>
+                <a:spcPct val="150000"/>
+              </a:lnSpc>
+              <a:spcAft>
+                <a:spcPts val="600"/>
+              </a:spcAft>
+            </a:pPr>
+            <a:r>
+              <a:rPr sz="3400" b="1">
+                <a:solidFill>
+                  <a:srgbClr val="003366"/>
+                </a:solidFill>
+                <a:latin typeface="Calibri"/>
+              </a:rPr>
+              <a:t>Web dashboard (Next.js + FastAPI)</a:t>
+            </a:r>
+          </a:p>
+        </p:txBody>
+      </p:sp>
+      <p:sp>
+        <p:nvSpPr>
+          <p:cNvPr id="4" name="TextBox 3"/>
+          <p:cNvSpPr txBox="1"/>
+          <p:nvPr/>
+        </p:nvSpPr>
+        <p:spPr>
+          <a:xfrm>
+            <a:off x="868680" y="1554480"/>
+            <a:ext cx="10607040" cy="4937760"/>
+          </a:xfrm>
+          <a:prstGeom prst="rect">
+            <a:avLst/>
+          </a:prstGeom>
+          <a:noFill/>
+        </p:spPr>
+        <p:txBody>
+          <a:bodyPr wrap="square">
+            <a:spAutoFit/>
+          </a:bodyPr>
+          <a:lstStyle/>
+          <a:p>
+            <a:pPr algn="l">
+              <a:lnSpc>
+                <a:spcPct val="150000"/>
+              </a:lnSpc>
+              <a:spcAft>
+                <a:spcPts val="1000"/>
+              </a:spcAft>
+            </a:pPr>
+            <a:r>
+              <a:rPr sz="2000" b="0">
+                <a:solidFill>
+                  <a:srgbClr val="1A1A1A"/>
+                </a:solidFill>
+                <a:latin typeface="Calibri"/>
+              </a:rPr>
+              <a:t>•  Real-time monitor: C/N₀, DOP, sat count + live 3-horizon prediction bars.</a:t>
+            </a:r>
+          </a:p>
+          <a:p>
+            <a:pPr algn="l">
+              <a:lnSpc>
+                <a:spcPct val="150000"/>
+              </a:lnSpc>
+              <a:spcAft>
+                <a:spcPts val="1000"/>
+              </a:spcAft>
+            </a:pPr>
+            <a:r>
+              <a:rPr sz="2000" b="0">
+                <a:solidFill>
+                  <a:srgbClr val="1A1A1A"/>
+                </a:solidFill>
+                <a:latin typeface="Calibri"/>
+              </a:rPr>
+              <a:t>•  Route map (Mapbox): colour-coded predicted signal quality along the planned path.</a:t>
+            </a:r>
+          </a:p>
+          <a:p>
+            <a:pPr algn="l">
+              <a:lnSpc>
+                <a:spcPct val="150000"/>
+              </a:lnSpc>
+              <a:spcAft>
+                <a:spcPts val="1000"/>
+              </a:spcAft>
+            </a:pPr>
+            <a:r>
+              <a:rPr sz="2000" b="0">
+                <a:solidFill>
+                  <a:srgbClr val="1A1A1A"/>
+                </a:solidFill>
+                <a:latin typeface="Calibri"/>
+              </a:rPr>
+              <a:t>•  Prediction timeline with lead-time annotations; attention heatmap for interpretability.</a:t>
+            </a:r>
+          </a:p>
+          <a:p>
+            <a:pPr algn="l">
+              <a:lnSpc>
+                <a:spcPct val="150000"/>
+              </a:lnSpc>
+              <a:spcAft>
+                <a:spcPts val="1000"/>
+              </a:spcAft>
+            </a:pPr>
+            <a:r>
+              <a:rPr sz="2000" b="0">
+                <a:solidFill>
+                  <a:srgbClr val="1A1A1A"/>
+                </a:solidFill>
+                <a:latin typeface="Calibri"/>
+              </a:rPr>
+              <a:t>•  DL-vs-baseline comparison; dataset explorer (149k epochs); metrics/performance board.</a:t>
+            </a:r>
+          </a:p>
+          <a:p>
+            <a:pPr algn="l">
+              <a:lnSpc>
+                <a:spcPct val="150000"/>
+              </a:lnSpc>
+              <a:spcAft>
+                <a:spcPts val="1000"/>
+              </a:spcAft>
+            </a:pPr>
+            <a:r>
+              <a:rPr sz="2000" b="0">
+                <a:solidFill>
+                  <a:srgbClr val="005BAC"/>
+                </a:solidFill>
+                <a:latin typeface="Calibri"/>
+              </a:rPr>
+              <a:t>•  Phase 2: integrate actual vehicle IMU; Kalman-filter fusion visualization.</a:t>
+            </a:r>
+          </a:p>
+        </p:txBody>
+      </p:sp>
+    </p:spTree>
+  </p:cSld>
+  <p:clrMapOvr>
+    <a:masterClrMapping/>
+  </p:clrMapOvr>
+</p:sld>
+</file>
+
+<file path=ppt/slides/slide36.xml><?xml version="1.0" encoding="utf-8"?>
+<p:sld xmlns:a="http://schemas.openxmlformats.org/drawingml/2006/main" xmlns:p="http://schemas.openxmlformats.org/presentationml/2006/main" xmlns:r="http://schemas.openxmlformats.org/officeDocument/2006/relationships">
+  <p:cSld>
+    <p:bg>
+      <p:bgPr>
+        <a:solidFill>
+          <a:srgbClr val="F5F8FC"/>
+        </a:solidFill>
+        <a:effectLst/>
+      </p:bgPr>
+    </p:bg>
+    <p:spTree>
+      <p:nvGrpSpPr>
+        <p:cNvPr id="1" name=""/>
+        <p:cNvGrpSpPr/>
+        <p:nvPr/>
+      </p:nvGrpSpPr>
+      <p:grpSpPr/>
+      <p:sp>
+        <p:nvSpPr>
+          <p:cNvPr id="2" name="Rectangle 1"/>
+          <p:cNvSpPr/>
+          <p:nvPr/>
+        </p:nvSpPr>
+        <p:spPr>
+          <a:xfrm>
+            <a:off x="548640" y="457200"/>
+            <a:ext cx="164592" cy="822960"/>
+          </a:xfrm>
+          <a:prstGeom prst="rect">
+            <a:avLst/>
+          </a:prstGeom>
+          <a:solidFill>
+            <a:srgbClr val="005BAC"/>
+          </a:solidFill>
+          <a:ln>
+            <a:noFill/>
+          </a:ln>
+        </p:spPr>
+        <p:style>
+          <a:lnRef idx="1">
+            <a:schemeClr val="accent1"/>
+          </a:lnRef>
+          <a:fillRef idx="3">
+            <a:schemeClr val="accent1"/>
+          </a:fillRef>
+          <a:effectRef idx="2">
+            <a:schemeClr val="accent1"/>
+          </a:effectRef>
+          <a:fontRef idx="minor">
+            <a:schemeClr val="lt1"/>
+          </a:fontRef>
+        </p:style>
+        <p:txBody>
+          <a:bodyPr rtlCol="0" anchor="ctr"/>
+          <a:lstStyle/>
+          <a:p>
+            <a:pPr algn="ctr"/>
+          </a:p>
+        </p:txBody>
+      </p:sp>
+      <p:sp>
+        <p:nvSpPr>
+          <p:cNvPr id="3" name="TextBox 2"/>
+          <p:cNvSpPr txBox="1"/>
+          <p:nvPr/>
+        </p:nvSpPr>
+        <p:spPr>
+          <a:xfrm>
+            <a:off x="868680" y="411480"/>
+            <a:ext cx="10789920" cy="914400"/>
+          </a:xfrm>
+          <a:prstGeom prst="rect">
+            <a:avLst/>
+          </a:prstGeom>
+          <a:noFill/>
+        </p:spPr>
+        <p:txBody>
+          <a:bodyPr wrap="square">
+            <a:spAutoFit/>
+          </a:bodyPr>
+          <a:lstStyle/>
+          <a:p>
+            <a:pPr algn="l">
+              <a:lnSpc>
+                <a:spcPct val="150000"/>
+              </a:lnSpc>
+              <a:spcAft>
+                <a:spcPts val="600"/>
+              </a:spcAft>
+            </a:pPr>
+            <a:r>
+              <a:rPr sz="3400" b="1">
+                <a:solidFill>
+                  <a:srgbClr val="003366"/>
+                </a:solidFill>
+                <a:latin typeface="Calibri"/>
+              </a:rPr>
+              <a:t>Publication &amp; reproducibility</a:t>
+            </a:r>
+          </a:p>
+        </p:txBody>
+      </p:sp>
+      <p:sp>
+        <p:nvSpPr>
+          <p:cNvPr id="4" name="TextBox 3"/>
+          <p:cNvSpPr txBox="1"/>
+          <p:nvPr/>
+        </p:nvSpPr>
+        <p:spPr>
+          <a:xfrm>
+            <a:off x="868680" y="1554480"/>
+            <a:ext cx="10607040" cy="4937760"/>
+          </a:xfrm>
+          <a:prstGeom prst="rect">
+            <a:avLst/>
+          </a:prstGeom>
+          <a:noFill/>
+        </p:spPr>
+        <p:txBody>
+          <a:bodyPr wrap="square">
+            <a:spAutoFit/>
+          </a:bodyPr>
+          <a:lstStyle/>
+          <a:p>
+            <a:pPr algn="l">
+              <a:lnSpc>
+                <a:spcPct val="150000"/>
+              </a:lnSpc>
+              <a:spcAft>
+                <a:spcPts val="1000"/>
+              </a:spcAft>
+            </a:pPr>
+            <a:r>
+              <a:rPr sz="2000" b="0">
+                <a:solidFill>
+                  <a:srgbClr val="005BAC"/>
+                </a:solidFill>
+                <a:latin typeface="Calibri"/>
+              </a:rPr>
+              <a:t>•  Paper A (GPS Solutions, Q1): method + multi-horizon + cross-receiver + cross-city.</a:t>
+            </a:r>
+          </a:p>
+          <a:p>
+            <a:pPr algn="l">
+              <a:lnSpc>
+                <a:spcPct val="150000"/>
+              </a:lnSpc>
+              <a:spcAft>
+                <a:spcPts val="1000"/>
+              </a:spcAft>
+            </a:pPr>
+            <a:r>
+              <a:rPr sz="2000" b="0">
+                <a:solidFill>
+                  <a:srgbClr val="1A1A1A"/>
+                </a:solidFill>
+                <a:latin typeface="Calibri"/>
+              </a:rPr>
+              <a:t>•  Paper B (Journal of Navigation): model comparison → ensemble selection → EKF integration.</a:t>
+            </a:r>
+          </a:p>
+          <a:p>
+            <a:pPr algn="l">
+              <a:lnSpc>
+                <a:spcPct val="150000"/>
+              </a:lnSpc>
+              <a:spcAft>
+                <a:spcPts val="1000"/>
+              </a:spcAft>
+            </a:pPr>
+            <a:r>
+              <a:rPr sz="2000" b="0">
+                <a:solidFill>
+                  <a:srgbClr val="1A1A1A"/>
+                </a:solidFill>
+                <a:latin typeface="Calibri"/>
+              </a:rPr>
+              <a:t>•  Conference (ION GNSS+ 2026): cross-city generalization result as a systems paper.</a:t>
+            </a:r>
+          </a:p>
+          <a:p>
+            <a:pPr algn="l">
+              <a:lnSpc>
+                <a:spcPct val="150000"/>
+              </a:lnSpc>
+              <a:spcAft>
+                <a:spcPts val="1000"/>
+              </a:spcAft>
+            </a:pPr>
+            <a:r>
+              <a:rPr sz="2000" b="0">
+                <a:solidFill>
+                  <a:srgbClr val="1A1A1A"/>
+                </a:solidFill>
+                <a:latin typeface="Calibri"/>
+              </a:rPr>
+              <a:t>•  Data + code release: GitHub + Zenodo (reproducible; citable DOI).</a:t>
+            </a:r>
+          </a:p>
+          <a:p>
+            <a:pPr algn="l">
+              <a:lnSpc>
+                <a:spcPct val="150000"/>
+              </a:lnSpc>
+              <a:spcAft>
+                <a:spcPts val="1000"/>
+              </a:spcAft>
+            </a:pPr>
+            <a:r>
+              <a:rPr sz="2000" b="0">
+                <a:solidFill>
+                  <a:srgbClr val="1A1A1A"/>
+                </a:solidFill>
+                <a:latin typeface="Calibri"/>
+              </a:rPr>
+              <a:t>•  All results / figures / models in results/ (zipped &amp; versioned).</a:t>
+            </a:r>
+          </a:p>
+        </p:txBody>
+      </p:sp>
+    </p:spTree>
+  </p:cSld>
+  <p:clrMapOvr>
+    <a:masterClrMapping/>
+  </p:clrMapOvr>
+</p:sld>
+</file>
+
+<file path=ppt/slides/slide37.xml><?xml version="1.0" encoding="utf-8"?>
 <p:sld xmlns:a="http://schemas.openxmlformats.org/drawingml/2006/main" xmlns:p="http://schemas.openxmlformats.org/presentationml/2006/main" xmlns:r="http://schemas.openxmlformats.org/officeDocument/2006/relationships">
   <p:cSld>
     <p:bg>

</xml_diff>